<commit_message>
[FHIR-47402](https://jira.hl7.org/browse/FHIR-47402). Updating VTE diagrams to replace DeviceUseStatement with Procedure. Note, agreed not to update Measure/MeasureReport example instances as described in the ticket (as need to coordinate with QMIG update)
</commit_message>
<xml_diff>
--- a/input/images/source/DEQM Resource Diagram - VTE.pptx
+++ b/input/images/source/DEQM Resource Diagram - VTE.pptx
@@ -223,7 +223,7 @@
           <a:p>
             <a:fld id="{4E266053-7327-E248-83C1-2353FC77D2E7}" type="datetimeFigureOut">
               <a:rPr lang="en-US" smtClean="0"/>
-              <a:t>4/16/2021</a:t>
+              <a:t>3/10/2026</a:t>
             </a:fld>
             <a:endParaRPr lang="en-US"/>
           </a:p>
@@ -518,6 +518,13 @@
           </p:nvPr>
         </p:nvSpPr>
         <p:spPr/>
+        <p:txBody>
+          <a:bodyPr/>
+          <a:lstStyle/>
+          <a:p>
+            <a:endParaRPr lang="en-US"/>
+          </a:p>
+        </p:txBody>
       </p:sp>
       <p:sp>
         <p:nvSpPr>
@@ -602,6 +609,13 @@
           </p:nvPr>
         </p:nvSpPr>
         <p:spPr/>
+        <p:txBody>
+          <a:bodyPr/>
+          <a:lstStyle/>
+          <a:p>
+            <a:endParaRPr lang="en-US"/>
+          </a:p>
+        </p:txBody>
       </p:sp>
       <p:sp>
         <p:nvSpPr>
@@ -840,7 +854,7 @@
           <a:p>
             <a:fld id="{7D2F21E0-95B6-4C5C-A55D-C5056E4C25C4}" type="datetimeFigureOut">
               <a:rPr lang="en-US" smtClean="0"/>
-              <a:t>4/16/2021</a:t>
+              <a:t>3/10/2026</a:t>
             </a:fld>
             <a:endParaRPr lang="en-US"/>
           </a:p>
@@ -1008,7 +1022,7 @@
           <a:p>
             <a:fld id="{7D2F21E0-95B6-4C5C-A55D-C5056E4C25C4}" type="datetimeFigureOut">
               <a:rPr lang="en-US" smtClean="0"/>
-              <a:t>4/16/2021</a:t>
+              <a:t>3/10/2026</a:t>
             </a:fld>
             <a:endParaRPr lang="en-US"/>
           </a:p>
@@ -1186,7 +1200,7 @@
           <a:p>
             <a:fld id="{7D2F21E0-95B6-4C5C-A55D-C5056E4C25C4}" type="datetimeFigureOut">
               <a:rPr lang="en-US" smtClean="0"/>
-              <a:t>4/16/2021</a:t>
+              <a:t>3/10/2026</a:t>
             </a:fld>
             <a:endParaRPr lang="en-US"/>
           </a:p>
@@ -1354,7 +1368,7 @@
           <a:p>
             <a:fld id="{7D2F21E0-95B6-4C5C-A55D-C5056E4C25C4}" type="datetimeFigureOut">
               <a:rPr lang="en-US" smtClean="0"/>
-              <a:t>4/16/2021</a:t>
+              <a:t>3/10/2026</a:t>
             </a:fld>
             <a:endParaRPr lang="en-US"/>
           </a:p>
@@ -1599,7 +1613,7 @@
           <a:p>
             <a:fld id="{7D2F21E0-95B6-4C5C-A55D-C5056E4C25C4}" type="datetimeFigureOut">
               <a:rPr lang="en-US" smtClean="0"/>
-              <a:t>4/16/2021</a:t>
+              <a:t>3/10/2026</a:t>
             </a:fld>
             <a:endParaRPr lang="en-US"/>
           </a:p>
@@ -1884,7 +1898,7 @@
           <a:p>
             <a:fld id="{7D2F21E0-95B6-4C5C-A55D-C5056E4C25C4}" type="datetimeFigureOut">
               <a:rPr lang="en-US" smtClean="0"/>
-              <a:t>4/16/2021</a:t>
+              <a:t>3/10/2026</a:t>
             </a:fld>
             <a:endParaRPr lang="en-US"/>
           </a:p>
@@ -2303,7 +2317,7 @@
           <a:p>
             <a:fld id="{7D2F21E0-95B6-4C5C-A55D-C5056E4C25C4}" type="datetimeFigureOut">
               <a:rPr lang="en-US" smtClean="0"/>
-              <a:t>4/16/2021</a:t>
+              <a:t>3/10/2026</a:t>
             </a:fld>
             <a:endParaRPr lang="en-US"/>
           </a:p>
@@ -2420,7 +2434,7 @@
           <a:p>
             <a:fld id="{7D2F21E0-95B6-4C5C-A55D-C5056E4C25C4}" type="datetimeFigureOut">
               <a:rPr lang="en-US" smtClean="0"/>
-              <a:t>4/16/2021</a:t>
+              <a:t>3/10/2026</a:t>
             </a:fld>
             <a:endParaRPr lang="en-US"/>
           </a:p>
@@ -2515,7 +2529,7 @@
           <a:p>
             <a:fld id="{7D2F21E0-95B6-4C5C-A55D-C5056E4C25C4}" type="datetimeFigureOut">
               <a:rPr lang="en-US" smtClean="0"/>
-              <a:t>4/16/2021</a:t>
+              <a:t>3/10/2026</a:t>
             </a:fld>
             <a:endParaRPr lang="en-US"/>
           </a:p>
@@ -2790,7 +2804,7 @@
           <a:p>
             <a:fld id="{7D2F21E0-95B6-4C5C-A55D-C5056E4C25C4}" type="datetimeFigureOut">
               <a:rPr lang="en-US" smtClean="0"/>
-              <a:t>4/16/2021</a:t>
+              <a:t>3/10/2026</a:t>
             </a:fld>
             <a:endParaRPr lang="en-US"/>
           </a:p>
@@ -3042,7 +3056,7 @@
           <a:p>
             <a:fld id="{7D2F21E0-95B6-4C5C-A55D-C5056E4C25C4}" type="datetimeFigureOut">
               <a:rPr lang="en-US" smtClean="0"/>
-              <a:t>4/16/2021</a:t>
+              <a:t>3/10/2026</a:t>
             </a:fld>
             <a:endParaRPr lang="en-US"/>
           </a:p>
@@ -3253,7 +3267,7 @@
           <a:p>
             <a:fld id="{7D2F21E0-95B6-4C5C-A55D-C5056E4C25C4}" type="datetimeFigureOut">
               <a:rPr lang="en-US" smtClean="0"/>
-              <a:t>4/16/2021</a:t>
+              <a:t>3/10/2026</a:t>
             </a:fld>
             <a:endParaRPr lang="en-US"/>
           </a:p>
@@ -9349,15 +9363,7 @@
           <a:p>
             <a:r>
               <a:rPr lang="en-US" sz="2400" dirty="0"/>
-              <a:t>MeasureReport using MedicationRequest, </a:t>
-            </a:r>
-            <a:r>
-              <a:rPr lang="en-US" sz="2400" dirty="0" err="1"/>
-              <a:t>MedicationStatement</a:t>
-            </a:r>
-            <a:r>
-              <a:rPr lang="en-US" sz="2400" dirty="0"/>
-              <a:t>, DeviceRequest or DeviceUseStatement</a:t>
+              <a:t>MeasureReport using MedicationRequest, MedicationStatement, DeviceRequest or DeviceUseStatement</a:t>
             </a:r>
           </a:p>
         </p:txBody>
@@ -11262,7 +11268,7 @@
                   <a:schemeClr val="bg1"/>
                 </a:solidFill>
               </a:rPr>
-              <a:t>DeviceRequest</a:t>
+              <a:t>ServiceRequest</a:t>
             </a:r>
           </a:p>
         </p:txBody>
@@ -11320,7 +11326,7 @@
                   <a:schemeClr val="bg1"/>
                 </a:solidFill>
               </a:rPr>
-              <a:t>DeviceUseStatement</a:t>
+              <a:t>Procedure</a:t>
             </a:r>
           </a:p>
         </p:txBody>
@@ -11463,8 +11469,8 @@
         </p:nvSpPr>
         <p:spPr>
           <a:xfrm>
-            <a:off x="2889780" y="5527963"/>
-            <a:ext cx="998552" cy="430887"/>
+            <a:off x="2769895" y="5591426"/>
+            <a:ext cx="1291578" cy="261610"/>
           </a:xfrm>
           <a:prstGeom prst="rect">
             <a:avLst/>
@@ -11482,14 +11488,7 @@
             <a:pPr algn="ctr"/>
             <a:r>
               <a:rPr lang="en-US" sz="1100" b="1" dirty="0"/>
-              <a:t>authoredOn/</a:t>
-            </a:r>
-          </a:p>
-          <a:p>
-            <a:pPr algn="ctr"/>
-            <a:r>
-              <a:rPr lang="en-US" sz="1100" b="1" dirty="0"/>
-              <a:t>recordedOn</a:t>
+              <a:t>performedPeriod</a:t>
             </a:r>
           </a:p>
         </p:txBody>
@@ -14790,7 +14789,7 @@
             <a:pPr algn="ctr"/>
             <a:r>
               <a:rPr lang="en-US" sz="1600" dirty="0"/>
-              <a:t>DeviceUseStatement</a:t>
+              <a:t>Procedure</a:t>
             </a:r>
           </a:p>
         </p:txBody>
@@ -15828,8 +15827,8 @@
         </p:nvSpPr>
         <p:spPr>
           <a:xfrm>
-            <a:off x="3611393" y="3883446"/>
-            <a:ext cx="655808" cy="261610"/>
+            <a:off x="3320734" y="3912487"/>
+            <a:ext cx="1113007" cy="261610"/>
           </a:xfrm>
           <a:prstGeom prst="rect">
             <a:avLst/>
@@ -15847,7 +15846,7 @@
             <a:pPr algn="ctr"/>
             <a:r>
               <a:rPr lang="en-US" sz="1100" b="1" dirty="0"/>
-              <a:t>device</a:t>
+              <a:t>usedReference</a:t>
             </a:r>
           </a:p>
         </p:txBody>
@@ -16112,8 +16111,8 @@
         </p:nvSpPr>
         <p:spPr>
           <a:xfrm>
-            <a:off x="4393351" y="4629298"/>
-            <a:ext cx="832066" cy="261610"/>
+            <a:off x="4087513" y="4620469"/>
+            <a:ext cx="1308801" cy="261610"/>
           </a:xfrm>
           <a:prstGeom prst="rect">
             <a:avLst/>
@@ -16131,7 +16130,7 @@
             <a:pPr algn="ctr"/>
             <a:r>
               <a:rPr lang="en-US" sz="1100" b="1" dirty="0"/>
-              <a:t>whenUsed</a:t>
+              <a:t>performedPeriod</a:t>
             </a:r>
           </a:p>
         </p:txBody>
@@ -19388,18 +19387,18 @@
 </file>
 
 <file path=customXml/item1.xml><?xml version="1.0" encoding="utf-8"?>
-<p:properties xmlns:p="http://schemas.microsoft.com/office/2006/metadata/properties" xmlns:xsi="http://www.w3.org/2001/XMLSchema-instance" xmlns:pc="http://schemas.microsoft.com/office/infopath/2007/PartnerControls">
-  <documentManagement/>
-</p:properties>
-</file>
-
-<file path=customXml/item2.xml><?xml version="1.0" encoding="utf-8"?>
 <?mso-contentType ?>
 <FormTemplates xmlns="http://schemas.microsoft.com/sharepoint/v3/contenttype/forms">
   <Display>DocumentLibraryForm</Display>
   <Edit>DocumentLibraryForm</Edit>
   <New>DocumentLibraryForm</New>
 </FormTemplates>
+</file>
+
+<file path=customXml/item2.xml><?xml version="1.0" encoding="utf-8"?>
+<p:properties xmlns:p="http://schemas.microsoft.com/office/2006/metadata/properties" xmlns:xsi="http://www.w3.org/2001/XMLSchema-instance" xmlns:pc="http://schemas.microsoft.com/office/infopath/2007/PartnerControls">
+  <documentManagement/>
+</p:properties>
 </file>
 
 <file path=customXml/item3.xml><?xml version="1.0" encoding="utf-8"?>
@@ -19588,6 +19587,14 @@
 </file>
 
 <file path=customXml/itemProps1.xml><?xml version="1.0" encoding="utf-8"?>
+<ds:datastoreItem xmlns:ds="http://schemas.openxmlformats.org/officeDocument/2006/customXml" ds:itemID="{7DF32799-2A9E-4894-A7BE-4A93586F7B79}">
+  <ds:schemaRefs>
+    <ds:schemaRef ds:uri="http://schemas.microsoft.com/sharepoint/v3/contenttype/forms"/>
+  </ds:schemaRefs>
+</ds:datastoreItem>
+</file>
+
+<file path=customXml/itemProps2.xml><?xml version="1.0" encoding="utf-8"?>
 <ds:datastoreItem xmlns:ds="http://schemas.openxmlformats.org/officeDocument/2006/customXml" ds:itemID="{90FDF430-C97A-4E13-9166-89CD4AE896F8}">
   <ds:schemaRefs>
     <ds:schemaRef ds:uri="http://schemas.microsoft.com/office/2006/documentManagement/types"/>
@@ -19600,14 +19607,6 @@
     <ds:schemaRef ds:uri="http://schemas.microsoft.com/office/infopath/2007/PartnerControls"/>
     <ds:schemaRef ds:uri="http://schemas.microsoft.com/office/2006/metadata/properties"/>
     <ds:schemaRef ds:uri="http://www.w3.org/XML/1998/namespace"/>
-  </ds:schemaRefs>
-</ds:datastoreItem>
-</file>
-
-<file path=customXml/itemProps2.xml><?xml version="1.0" encoding="utf-8"?>
-<ds:datastoreItem xmlns:ds="http://schemas.openxmlformats.org/officeDocument/2006/customXml" ds:itemID="{7DF32799-2A9E-4894-A7BE-4A93586F7B79}">
-  <ds:schemaRefs>
-    <ds:schemaRef ds:uri="http://schemas.microsoft.com/sharepoint/v3/contenttype/forms"/>
   </ds:schemaRefs>
 </ds:datastoreItem>
 </file>

</xml_diff>

<commit_message>
[47402](https://jira.hl7.org/browse/FHIR-47402): Suggest updating "Example Use Cases" info. Tweaking VTE image titles to remove DeviceUseStatement from header text
</commit_message>
<xml_diff>
--- a/input/images/source/DEQM Resource Diagram - VTE.pptx
+++ b/input/images/source/DEQM Resource Diagram - VTE.pptx
@@ -223,7 +223,7 @@
           <a:p>
             <a:fld id="{4E266053-7327-E248-83C1-2353FC77D2E7}" type="datetimeFigureOut">
               <a:rPr lang="en-US" smtClean="0"/>
-              <a:t>4/16/2021</a:t>
+              <a:t>3/11/2026</a:t>
             </a:fld>
             <a:endParaRPr lang="en-US"/>
           </a:p>
@@ -518,6 +518,13 @@
           </p:nvPr>
         </p:nvSpPr>
         <p:spPr/>
+        <p:txBody>
+          <a:bodyPr/>
+          <a:lstStyle/>
+          <a:p>
+            <a:endParaRPr lang="en-US"/>
+          </a:p>
+        </p:txBody>
       </p:sp>
       <p:sp>
         <p:nvSpPr>
@@ -602,6 +609,13 @@
           </p:nvPr>
         </p:nvSpPr>
         <p:spPr/>
+        <p:txBody>
+          <a:bodyPr/>
+          <a:lstStyle/>
+          <a:p>
+            <a:endParaRPr lang="en-US"/>
+          </a:p>
+        </p:txBody>
       </p:sp>
       <p:sp>
         <p:nvSpPr>
@@ -840,7 +854,7 @@
           <a:p>
             <a:fld id="{7D2F21E0-95B6-4C5C-A55D-C5056E4C25C4}" type="datetimeFigureOut">
               <a:rPr lang="en-US" smtClean="0"/>
-              <a:t>4/16/2021</a:t>
+              <a:t>3/11/2026</a:t>
             </a:fld>
             <a:endParaRPr lang="en-US"/>
           </a:p>
@@ -1008,7 +1022,7 @@
           <a:p>
             <a:fld id="{7D2F21E0-95B6-4C5C-A55D-C5056E4C25C4}" type="datetimeFigureOut">
               <a:rPr lang="en-US" smtClean="0"/>
-              <a:t>4/16/2021</a:t>
+              <a:t>3/11/2026</a:t>
             </a:fld>
             <a:endParaRPr lang="en-US"/>
           </a:p>
@@ -1186,7 +1200,7 @@
           <a:p>
             <a:fld id="{7D2F21E0-95B6-4C5C-A55D-C5056E4C25C4}" type="datetimeFigureOut">
               <a:rPr lang="en-US" smtClean="0"/>
-              <a:t>4/16/2021</a:t>
+              <a:t>3/11/2026</a:t>
             </a:fld>
             <a:endParaRPr lang="en-US"/>
           </a:p>
@@ -1354,7 +1368,7 @@
           <a:p>
             <a:fld id="{7D2F21E0-95B6-4C5C-A55D-C5056E4C25C4}" type="datetimeFigureOut">
               <a:rPr lang="en-US" smtClean="0"/>
-              <a:t>4/16/2021</a:t>
+              <a:t>3/11/2026</a:t>
             </a:fld>
             <a:endParaRPr lang="en-US"/>
           </a:p>
@@ -1599,7 +1613,7 @@
           <a:p>
             <a:fld id="{7D2F21E0-95B6-4C5C-A55D-C5056E4C25C4}" type="datetimeFigureOut">
               <a:rPr lang="en-US" smtClean="0"/>
-              <a:t>4/16/2021</a:t>
+              <a:t>3/11/2026</a:t>
             </a:fld>
             <a:endParaRPr lang="en-US"/>
           </a:p>
@@ -1884,7 +1898,7 @@
           <a:p>
             <a:fld id="{7D2F21E0-95B6-4C5C-A55D-C5056E4C25C4}" type="datetimeFigureOut">
               <a:rPr lang="en-US" smtClean="0"/>
-              <a:t>4/16/2021</a:t>
+              <a:t>3/11/2026</a:t>
             </a:fld>
             <a:endParaRPr lang="en-US"/>
           </a:p>
@@ -2303,7 +2317,7 @@
           <a:p>
             <a:fld id="{7D2F21E0-95B6-4C5C-A55D-C5056E4C25C4}" type="datetimeFigureOut">
               <a:rPr lang="en-US" smtClean="0"/>
-              <a:t>4/16/2021</a:t>
+              <a:t>3/11/2026</a:t>
             </a:fld>
             <a:endParaRPr lang="en-US"/>
           </a:p>
@@ -2420,7 +2434,7 @@
           <a:p>
             <a:fld id="{7D2F21E0-95B6-4C5C-A55D-C5056E4C25C4}" type="datetimeFigureOut">
               <a:rPr lang="en-US" smtClean="0"/>
-              <a:t>4/16/2021</a:t>
+              <a:t>3/11/2026</a:t>
             </a:fld>
             <a:endParaRPr lang="en-US"/>
           </a:p>
@@ -2515,7 +2529,7 @@
           <a:p>
             <a:fld id="{7D2F21E0-95B6-4C5C-A55D-C5056E4C25C4}" type="datetimeFigureOut">
               <a:rPr lang="en-US" smtClean="0"/>
-              <a:t>4/16/2021</a:t>
+              <a:t>3/11/2026</a:t>
             </a:fld>
             <a:endParaRPr lang="en-US"/>
           </a:p>
@@ -2790,7 +2804,7 @@
           <a:p>
             <a:fld id="{7D2F21E0-95B6-4C5C-A55D-C5056E4C25C4}" type="datetimeFigureOut">
               <a:rPr lang="en-US" smtClean="0"/>
-              <a:t>4/16/2021</a:t>
+              <a:t>3/11/2026</a:t>
             </a:fld>
             <a:endParaRPr lang="en-US"/>
           </a:p>
@@ -3042,7 +3056,7 @@
           <a:p>
             <a:fld id="{7D2F21E0-95B6-4C5C-A55D-C5056E4C25C4}" type="datetimeFigureOut">
               <a:rPr lang="en-US" smtClean="0"/>
-              <a:t>4/16/2021</a:t>
+              <a:t>3/11/2026</a:t>
             </a:fld>
             <a:endParaRPr lang="en-US"/>
           </a:p>
@@ -3253,7 +3267,7 @@
           <a:p>
             <a:fld id="{7D2F21E0-95B6-4C5C-A55D-C5056E4C25C4}" type="datetimeFigureOut">
               <a:rPr lang="en-US" smtClean="0"/>
-              <a:t>4/16/2021</a:t>
+              <a:t>3/11/2026</a:t>
             </a:fld>
             <a:endParaRPr lang="en-US"/>
           </a:p>
@@ -9349,15 +9363,7 @@
           <a:p>
             <a:r>
               <a:rPr lang="en-US" sz="2400" dirty="0"/>
-              <a:t>MeasureReport using MedicationRequest, </a:t>
-            </a:r>
-            <a:r>
-              <a:rPr lang="en-US" sz="2400" dirty="0" err="1"/>
-              <a:t>MedicationStatement</a:t>
-            </a:r>
-            <a:r>
-              <a:rPr lang="en-US" sz="2400" dirty="0"/>
-              <a:t>, DeviceRequest or DeviceUseStatement</a:t>
+              <a:t>MeasureReport using MedicationRequest, MedicationStatement, ServiceRequest or Procedure</a:t>
             </a:r>
           </a:p>
         </p:txBody>
@@ -11262,7 +11268,7 @@
                   <a:schemeClr val="bg1"/>
                 </a:solidFill>
               </a:rPr>
-              <a:t>DeviceRequest</a:t>
+              <a:t>ServiceRequest</a:t>
             </a:r>
           </a:p>
         </p:txBody>
@@ -11320,7 +11326,7 @@
                   <a:schemeClr val="bg1"/>
                 </a:solidFill>
               </a:rPr>
-              <a:t>DeviceUseStatement</a:t>
+              <a:t>Procedure</a:t>
             </a:r>
           </a:p>
         </p:txBody>
@@ -11463,8 +11469,8 @@
         </p:nvSpPr>
         <p:spPr>
           <a:xfrm>
-            <a:off x="2889780" y="5527963"/>
-            <a:ext cx="998552" cy="430887"/>
+            <a:off x="2736410" y="5573434"/>
+            <a:ext cx="1352522" cy="261610"/>
           </a:xfrm>
           <a:prstGeom prst="rect">
             <a:avLst/>
@@ -11482,14 +11488,7 @@
             <a:pPr algn="ctr"/>
             <a:r>
               <a:rPr lang="en-US" sz="1100" b="1" dirty="0"/>
-              <a:t>authoredOn/</a:t>
-            </a:r>
-          </a:p>
-          <a:p>
-            <a:pPr algn="ctr"/>
-            <a:r>
-              <a:rPr lang="en-US" sz="1100" b="1" dirty="0"/>
-              <a:t>recordedOn</a:t>
+              <a:t>performedPeriod</a:t>
             </a:r>
           </a:p>
         </p:txBody>
@@ -14660,7 +14659,7 @@
           <a:p>
             <a:r>
               <a:rPr lang="en-US" sz="2400" dirty="0"/>
-              <a:t>MeasureReport using DeviceUseStatement and Encounter</a:t>
+              <a:t>MeasureReport using Procedure and Encounter</a:t>
             </a:r>
           </a:p>
         </p:txBody>
@@ -14790,7 +14789,7 @@
             <a:pPr algn="ctr"/>
             <a:r>
               <a:rPr lang="en-US" sz="1600" dirty="0"/>
-              <a:t>DeviceUseStatement</a:t>
+              <a:t>Procedure</a:t>
             </a:r>
           </a:p>
         </p:txBody>
@@ -15828,8 +15827,8 @@
         </p:nvSpPr>
         <p:spPr>
           <a:xfrm>
-            <a:off x="3611393" y="3883446"/>
-            <a:ext cx="655808" cy="261610"/>
+            <a:off x="3351061" y="3947289"/>
+            <a:ext cx="1052398" cy="261610"/>
           </a:xfrm>
           <a:prstGeom prst="rect">
             <a:avLst/>
@@ -15847,7 +15846,7 @@
             <a:pPr algn="ctr"/>
             <a:r>
               <a:rPr lang="en-US" sz="1100" b="1" dirty="0"/>
-              <a:t>device</a:t>
+              <a:t>usedReference</a:t>
             </a:r>
           </a:p>
         </p:txBody>
@@ -16112,8 +16111,8 @@
         </p:nvSpPr>
         <p:spPr>
           <a:xfrm>
-            <a:off x="4393351" y="4629298"/>
-            <a:ext cx="832066" cy="261610"/>
+            <a:off x="4256609" y="4637618"/>
+            <a:ext cx="1308801" cy="261610"/>
           </a:xfrm>
           <a:prstGeom prst="rect">
             <a:avLst/>
@@ -16131,7 +16130,7 @@
             <a:pPr algn="ctr"/>
             <a:r>
               <a:rPr lang="en-US" sz="1100" b="1" dirty="0"/>
-              <a:t>whenUsed</a:t>
+              <a:t>performedPeriod</a:t>
             </a:r>
           </a:p>
         </p:txBody>
@@ -19388,21 +19387,6 @@
 </file>
 
 <file path=customXml/item1.xml><?xml version="1.0" encoding="utf-8"?>
-<p:properties xmlns:p="http://schemas.microsoft.com/office/2006/metadata/properties" xmlns:xsi="http://www.w3.org/2001/XMLSchema-instance" xmlns:pc="http://schemas.microsoft.com/office/infopath/2007/PartnerControls">
-  <documentManagement/>
-</p:properties>
-</file>
-
-<file path=customXml/item2.xml><?xml version="1.0" encoding="utf-8"?>
-<?mso-contentType ?>
-<FormTemplates xmlns="http://schemas.microsoft.com/sharepoint/v3/contenttype/forms">
-  <Display>DocumentLibraryForm</Display>
-  <Edit>DocumentLibraryForm</Edit>
-  <New>DocumentLibraryForm</New>
-</FormTemplates>
-</file>
-
-<file path=customXml/item3.xml><?xml version="1.0" encoding="utf-8"?>
 <ct:contentTypeSchema xmlns:ct="http://schemas.microsoft.com/office/2006/metadata/contentType" xmlns:ma="http://schemas.microsoft.com/office/2006/metadata/properties/metaAttributes" ct:_="" ma:_="" ma:contentTypeName="Document" ma:contentTypeID="0x010100E266619F3A8DA84E844CC332E58F8D49" ma:contentTypeVersion="7" ma:contentTypeDescription="Create a new document." ma:contentTypeScope="" ma:versionID="5d8a838ea32704de551bbf800a2359a5">
   <xsd:schema xmlns:xsd="http://www.w3.org/2001/XMLSchema" xmlns:xs="http://www.w3.org/2001/XMLSchema" xmlns:p="http://schemas.microsoft.com/office/2006/metadata/properties" xmlns:ns2="86583c5b-2812-43c9-9d95-43036731b97a" xmlns:ns3="a55e4437-922f-4c3b-a618-0f40b608b01d" targetNamespace="http://schemas.microsoft.com/office/2006/metadata/properties" ma:root="true" ma:fieldsID="403b19a14513e6057a21c0d89da04aa3" ns2:_="" ns3:_="">
     <xsd:import namespace="86583c5b-2812-43c9-9d95-43036731b97a"/>
@@ -19587,32 +19571,22 @@
 </ct:contentTypeSchema>
 </file>
 
-<file path=customXml/itemProps1.xml><?xml version="1.0" encoding="utf-8"?>
-<ds:datastoreItem xmlns:ds="http://schemas.openxmlformats.org/officeDocument/2006/customXml" ds:itemID="{90FDF430-C97A-4E13-9166-89CD4AE896F8}">
-  <ds:schemaRefs>
-    <ds:schemaRef ds:uri="http://schemas.microsoft.com/office/2006/documentManagement/types"/>
-    <ds:schemaRef ds:uri="http://purl.org/dc/elements/1.1/"/>
-    <ds:schemaRef ds:uri="http://schemas.openxmlformats.org/package/2006/metadata/core-properties"/>
-    <ds:schemaRef ds:uri="http://purl.org/dc/terms/"/>
-    <ds:schemaRef ds:uri="http://purl.org/dc/dcmitype/"/>
-    <ds:schemaRef ds:uri="86583c5b-2812-43c9-9d95-43036731b97a"/>
-    <ds:schemaRef ds:uri="a55e4437-922f-4c3b-a618-0f40b608b01d"/>
-    <ds:schemaRef ds:uri="http://schemas.microsoft.com/office/infopath/2007/PartnerControls"/>
-    <ds:schemaRef ds:uri="http://schemas.microsoft.com/office/2006/metadata/properties"/>
-    <ds:schemaRef ds:uri="http://www.w3.org/XML/1998/namespace"/>
-  </ds:schemaRefs>
-</ds:datastoreItem>
+<file path=customXml/item2.xml><?xml version="1.0" encoding="utf-8"?>
+<?mso-contentType ?>
+<FormTemplates xmlns="http://schemas.microsoft.com/sharepoint/v3/contenttype/forms">
+  <Display>DocumentLibraryForm</Display>
+  <Edit>DocumentLibraryForm</Edit>
+  <New>DocumentLibraryForm</New>
+</FormTemplates>
 </file>
 
-<file path=customXml/itemProps2.xml><?xml version="1.0" encoding="utf-8"?>
-<ds:datastoreItem xmlns:ds="http://schemas.openxmlformats.org/officeDocument/2006/customXml" ds:itemID="{7DF32799-2A9E-4894-A7BE-4A93586F7B79}">
-  <ds:schemaRefs>
-    <ds:schemaRef ds:uri="http://schemas.microsoft.com/sharepoint/v3/contenttype/forms"/>
-  </ds:schemaRefs>
-</ds:datastoreItem>
+<file path=customXml/item3.xml><?xml version="1.0" encoding="utf-8"?>
+<p:properties xmlns:p="http://schemas.microsoft.com/office/2006/metadata/properties" xmlns:xsi="http://www.w3.org/2001/XMLSchema-instance" xmlns:pc="http://schemas.microsoft.com/office/infopath/2007/PartnerControls">
+  <documentManagement/>
+</p:properties>
 </file>
 
-<file path=customXml/itemProps3.xml><?xml version="1.0" encoding="utf-8"?>
+<file path=customXml/itemProps1.xml><?xml version="1.0" encoding="utf-8"?>
 <ds:datastoreItem xmlns:ds="http://schemas.openxmlformats.org/officeDocument/2006/customXml" ds:itemID="{57D1FF20-1285-4672-9577-89C47B976660}">
   <ds:schemaRefs>
     <ds:schemaRef ds:uri="http://schemas.microsoft.com/office/2006/metadata/contentType"/>
@@ -19629,4 +19603,29 @@
     <ds:schemaRef ds:uri="http://schemas.microsoft.com/internal/obd"/>
   </ds:schemaRefs>
 </ds:datastoreItem>
+</file>
+
+<file path=customXml/itemProps2.xml><?xml version="1.0" encoding="utf-8"?>
+<ds:datastoreItem xmlns:ds="http://schemas.openxmlformats.org/officeDocument/2006/customXml" ds:itemID="{7DF32799-2A9E-4894-A7BE-4A93586F7B79}">
+  <ds:schemaRefs>
+    <ds:schemaRef ds:uri="http://schemas.microsoft.com/sharepoint/v3/contenttype/forms"/>
+  </ds:schemaRefs>
+</ds:datastoreItem>
+</file>
+
+<file path=customXml/itemProps3.xml><?xml version="1.0" encoding="utf-8"?>
+<ds:datastoreItem xmlns:ds="http://schemas.openxmlformats.org/officeDocument/2006/customXml" ds:itemID="{90FDF430-C97A-4E13-9166-89CD4AE896F8}">
+  <ds:schemaRefs>
+    <ds:schemaRef ds:uri="http://schemas.microsoft.com/office/2006/documentManagement/types"/>
+    <ds:schemaRef ds:uri="http://purl.org/dc/elements/1.1/"/>
+    <ds:schemaRef ds:uri="http://schemas.openxmlformats.org/package/2006/metadata/core-properties"/>
+    <ds:schemaRef ds:uri="http://purl.org/dc/terms/"/>
+    <ds:schemaRef ds:uri="http://purl.org/dc/dcmitype/"/>
+    <ds:schemaRef ds:uri="86583c5b-2812-43c9-9d95-43036731b97a"/>
+    <ds:schemaRef ds:uri="a55e4437-922f-4c3b-a618-0f40b608b01d"/>
+    <ds:schemaRef ds:uri="http://schemas.microsoft.com/office/infopath/2007/PartnerControls"/>
+    <ds:schemaRef ds:uri="http://schemas.microsoft.com/office/2006/metadata/properties"/>
+    <ds:schemaRef ds:uri="http://www.w3.org/XML/1998/namespace"/>
+  </ds:schemaRefs>
+</ds:datastoreItem>
 </file>
</xml_diff>